<commit_message>
Address more of Rich's feedback
</commit_message>
<xml_diff>
--- a/2016/09-Sep/introducing-dotnet-standard-20/graphics.pptx
+++ b/2016/09-Sep/introducing-dotnet-standard-20/graphics.pptx
@@ -7,8 +7,9 @@
   <p:sldIdLst>
     <p:sldId id="259" r:id="rId2"/>
     <p:sldId id="260" r:id="rId3"/>
-    <p:sldId id="256" r:id="rId4"/>
-    <p:sldId id="261" r:id="rId5"/>
+    <p:sldId id="262" r:id="rId4"/>
+    <p:sldId id="256" r:id="rId5"/>
+    <p:sldId id="261" r:id="rId6"/>
   </p:sldIdLst>
   <p:sldSz cx="12192000" cy="6858000"/>
   <p:notesSz cx="6858000" cy="9144000"/>
@@ -244,7 +245,7 @@
           <a:p>
             <a:fld id="{56683E47-5F36-48BA-9B57-B18F4BD69A91}" type="datetimeFigureOut">
               <a:rPr lang="en-US" smtClean="0"/>
-              <a:t>9/16/2016</a:t>
+              <a:t>9/23/2016</a:t>
             </a:fld>
             <a:endParaRPr lang="en-US"/>
           </a:p>
@@ -412,7 +413,7 @@
           <a:p>
             <a:fld id="{56683E47-5F36-48BA-9B57-B18F4BD69A91}" type="datetimeFigureOut">
               <a:rPr lang="en-US" smtClean="0"/>
-              <a:t>9/16/2016</a:t>
+              <a:t>9/23/2016</a:t>
             </a:fld>
             <a:endParaRPr lang="en-US"/>
           </a:p>
@@ -590,7 +591,7 @@
           <a:p>
             <a:fld id="{56683E47-5F36-48BA-9B57-B18F4BD69A91}" type="datetimeFigureOut">
               <a:rPr lang="en-US" smtClean="0"/>
-              <a:t>9/16/2016</a:t>
+              <a:t>9/23/2016</a:t>
             </a:fld>
             <a:endParaRPr lang="en-US"/>
           </a:p>
@@ -758,7 +759,7 @@
           <a:p>
             <a:fld id="{56683E47-5F36-48BA-9B57-B18F4BD69A91}" type="datetimeFigureOut">
               <a:rPr lang="en-US" smtClean="0"/>
-              <a:t>9/16/2016</a:t>
+              <a:t>9/23/2016</a:t>
             </a:fld>
             <a:endParaRPr lang="en-US"/>
           </a:p>
@@ -1003,7 +1004,7 @@
           <a:p>
             <a:fld id="{56683E47-5F36-48BA-9B57-B18F4BD69A91}" type="datetimeFigureOut">
               <a:rPr lang="en-US" smtClean="0"/>
-              <a:t>9/16/2016</a:t>
+              <a:t>9/23/2016</a:t>
             </a:fld>
             <a:endParaRPr lang="en-US"/>
           </a:p>
@@ -1232,7 +1233,7 @@
           <a:p>
             <a:fld id="{56683E47-5F36-48BA-9B57-B18F4BD69A91}" type="datetimeFigureOut">
               <a:rPr lang="en-US" smtClean="0"/>
-              <a:t>9/16/2016</a:t>
+              <a:t>9/23/2016</a:t>
             </a:fld>
             <a:endParaRPr lang="en-US"/>
           </a:p>
@@ -1596,7 +1597,7 @@
           <a:p>
             <a:fld id="{56683E47-5F36-48BA-9B57-B18F4BD69A91}" type="datetimeFigureOut">
               <a:rPr lang="en-US" smtClean="0"/>
-              <a:t>9/16/2016</a:t>
+              <a:t>9/23/2016</a:t>
             </a:fld>
             <a:endParaRPr lang="en-US"/>
           </a:p>
@@ -1713,7 +1714,7 @@
           <a:p>
             <a:fld id="{56683E47-5F36-48BA-9B57-B18F4BD69A91}" type="datetimeFigureOut">
               <a:rPr lang="en-US" smtClean="0"/>
-              <a:t>9/16/2016</a:t>
+              <a:t>9/23/2016</a:t>
             </a:fld>
             <a:endParaRPr lang="en-US"/>
           </a:p>
@@ -1808,7 +1809,7 @@
           <a:p>
             <a:fld id="{56683E47-5F36-48BA-9B57-B18F4BD69A91}" type="datetimeFigureOut">
               <a:rPr lang="en-US" smtClean="0"/>
-              <a:t>9/16/2016</a:t>
+              <a:t>9/23/2016</a:t>
             </a:fld>
             <a:endParaRPr lang="en-US"/>
           </a:p>
@@ -2083,7 +2084,7 @@
           <a:p>
             <a:fld id="{56683E47-5F36-48BA-9B57-B18F4BD69A91}" type="datetimeFigureOut">
               <a:rPr lang="en-US" smtClean="0"/>
-              <a:t>9/16/2016</a:t>
+              <a:t>9/23/2016</a:t>
             </a:fld>
             <a:endParaRPr lang="en-US"/>
           </a:p>
@@ -2335,7 +2336,7 @@
           <a:p>
             <a:fld id="{56683E47-5F36-48BA-9B57-B18F4BD69A91}" type="datetimeFigureOut">
               <a:rPr lang="en-US" smtClean="0"/>
-              <a:t>9/16/2016</a:t>
+              <a:t>9/23/2016</a:t>
             </a:fld>
             <a:endParaRPr lang="en-US"/>
           </a:p>
@@ -2546,7 +2547,7 @@
           <a:p>
             <a:fld id="{56683E47-5F36-48BA-9B57-B18F4BD69A91}" type="datetimeFigureOut">
               <a:rPr lang="en-US" smtClean="0"/>
-              <a:t>9/16/2016</a:t>
+              <a:t>9/23/2016</a:t>
             </a:fld>
             <a:endParaRPr lang="en-US"/>
           </a:p>
@@ -6759,6 +6760,1845 @@
       </p:grpSpPr>
       <p:sp>
         <p:nvSpPr>
+          <p:cNvPr id="26" name="TextBox 25"/>
+          <p:cNvSpPr txBox="1"/>
+          <p:nvPr/>
+        </p:nvSpPr>
+        <p:spPr>
+          <a:xfrm>
+            <a:off x="1585283" y="579377"/>
+            <a:ext cx="9217395" cy="6092553"/>
+          </a:xfrm>
+          <a:prstGeom prst="rect">
+            <a:avLst/>
+          </a:prstGeom>
+          <a:solidFill>
+            <a:srgbClr val="CFCFCF"/>
+          </a:solidFill>
+          <a:ln w="38100">
+            <a:solidFill>
+              <a:srgbClr val="505050"/>
+            </a:solidFill>
+          </a:ln>
+        </p:spPr>
+        <p:txBody>
+          <a:bodyPr wrap="square" lIns="179285" tIns="143428" rIns="179285" bIns="143428" rtlCol="0" anchor="ctr">
+            <a:noAutofit/>
+          </a:bodyPr>
+          <a:lstStyle>
+            <a:defPPr>
+              <a:defRPr lang="en-US"/>
+            </a:defPPr>
+            <a:lvl1pPr algn="ctr" defTabSz="914224">
+              <a:lnSpc>
+                <a:spcPct val="90000"/>
+              </a:lnSpc>
+              <a:defRPr sz="2000" kern="0">
+                <a:gradFill>
+                  <a:gsLst>
+                    <a:gs pos="1250">
+                      <a:srgbClr val="FFFFFF"/>
+                    </a:gs>
+                    <a:gs pos="100000">
+                      <a:srgbClr val="FFFFFF"/>
+                    </a:gs>
+                  </a:gsLst>
+                  <a:lin ang="5400000" scaled="0"/>
+                </a:gradFill>
+                <a:latin typeface="Segoe UI Semibold" panose="020B0702040204020203" pitchFamily="34" charset="0"/>
+                <a:cs typeface="Segoe UI Semibold" panose="020B0702040204020203" pitchFamily="34" charset="0"/>
+              </a:defRPr>
+            </a:lvl1pPr>
+          </a:lstStyle>
+          <a:p>
+            <a:pPr marL="0" marR="0" lvl="0" indent="0" algn="ctr" defTabSz="914224" eaLnBrk="1" fontAlgn="auto" latinLnBrk="0" hangingPunct="1">
+              <a:lnSpc>
+                <a:spcPct val="90000"/>
+              </a:lnSpc>
+              <a:spcBef>
+                <a:spcPts val="0"/>
+              </a:spcBef>
+              <a:spcAft>
+                <a:spcPts val="0"/>
+              </a:spcAft>
+              <a:buClrTx/>
+              <a:buSzTx/>
+              <a:buFontTx/>
+              <a:buNone/>
+              <a:tabLst/>
+              <a:defRPr/>
+            </a:pPr>
+            <a:endParaRPr kumimoji="0" lang="en-US" sz="1765" b="0" i="0" u="none" strike="noStrike" kern="0" cap="none" spc="0" normalizeH="0" baseline="0" noProof="0" dirty="0">
+              <a:ln>
+                <a:noFill/>
+              </a:ln>
+              <a:gradFill>
+                <a:gsLst>
+                  <a:gs pos="1250">
+                    <a:srgbClr val="FFFFFF"/>
+                  </a:gs>
+                  <a:gs pos="100000">
+                    <a:srgbClr val="FFFFFF"/>
+                  </a:gs>
+                </a:gsLst>
+                <a:lin ang="5400000" scaled="0"/>
+              </a:gradFill>
+              <a:effectLst/>
+              <a:uLnTx/>
+              <a:uFillTx/>
+              <a:latin typeface="Segoe UI"/>
+              <a:cs typeface="Segoe UI Semibold" panose="020B0702040204020203" pitchFamily="34" charset="0"/>
+            </a:endParaRPr>
+          </a:p>
+        </p:txBody>
+      </p:sp>
+      <p:grpSp>
+        <p:nvGrpSpPr>
+          <p:cNvPr id="2" name="Group 1"/>
+          <p:cNvGrpSpPr/>
+          <p:nvPr/>
+        </p:nvGrpSpPr>
+        <p:grpSpPr>
+          <a:xfrm>
+            <a:off x="1945213" y="5843438"/>
+            <a:ext cx="8515943" cy="537849"/>
+            <a:chOff x="1646287" y="5572667"/>
+            <a:chExt cx="8686705" cy="548634"/>
+          </a:xfrm>
+        </p:grpSpPr>
+        <p:sp>
+          <p:nvSpPr>
+            <p:cNvPr id="3" name="Rectangle 2"/>
+            <p:cNvSpPr/>
+            <p:nvPr/>
+          </p:nvSpPr>
+          <p:spPr bwMode="auto">
+            <a:xfrm>
+              <a:off x="1646287" y="5572667"/>
+              <a:ext cx="8686705" cy="548634"/>
+            </a:xfrm>
+            <a:prstGeom prst="rect">
+              <a:avLst/>
+            </a:prstGeom>
+            <a:ln>
+              <a:noFill/>
+              <a:headEnd type="none" w="med" len="med"/>
+              <a:tailEnd type="none" w="med" len="med"/>
+            </a:ln>
+          </p:spPr>
+          <p:style>
+            <a:lnRef idx="2">
+              <a:schemeClr val="accent1">
+                <a:shade val="50000"/>
+              </a:schemeClr>
+            </a:lnRef>
+            <a:fillRef idx="1">
+              <a:schemeClr val="accent1"/>
+            </a:fillRef>
+            <a:effectRef idx="0">
+              <a:schemeClr val="accent1"/>
+            </a:effectRef>
+            <a:fontRef idx="minor">
+              <a:schemeClr val="lt1"/>
+            </a:fontRef>
+          </p:style>
+          <p:txBody>
+            <a:bodyPr rot="0" spcFirstLastPara="0" vertOverflow="overflow" horzOverflow="overflow" vert="horz" wrap="square" lIns="0" tIns="45720" rIns="0" bIns="45720" numCol="1" spcCol="0" rtlCol="0" fromWordArt="0" anchor="ctr" anchorCtr="0" forceAA="0" compatLnSpc="1">
+              <a:prstTxWarp prst="textNoShape">
+                <a:avLst/>
+              </a:prstTxWarp>
+              <a:noAutofit/>
+            </a:bodyPr>
+            <a:lstStyle/>
+            <a:p>
+              <a:pPr algn="ctr" defTabSz="914102" fontAlgn="base">
+                <a:spcBef>
+                  <a:spcPct val="0"/>
+                </a:spcBef>
+                <a:spcAft>
+                  <a:spcPct val="0"/>
+                </a:spcAft>
+              </a:pPr>
+              <a:endParaRPr lang="en-US" sz="1961" kern="0" dirty="0">
+                <a:gradFill>
+                  <a:gsLst>
+                    <a:gs pos="5439">
+                      <a:srgbClr val="F8F8F8"/>
+                    </a:gs>
+                    <a:gs pos="10000">
+                      <a:srgbClr val="F8F8F8"/>
+                    </a:gs>
+                  </a:gsLst>
+                  <a:lin ang="5400000" scaled="0"/>
+                </a:gradFill>
+              </a:endParaRPr>
+            </a:p>
+          </p:txBody>
+        </p:sp>
+        <p:sp>
+          <p:nvSpPr>
+            <p:cNvPr id="4" name="TextBox 3"/>
+            <p:cNvSpPr txBox="1"/>
+            <p:nvPr/>
+          </p:nvSpPr>
+          <p:spPr>
+            <a:xfrm>
+              <a:off x="4480896" y="5574602"/>
+              <a:ext cx="5577780" cy="544765"/>
+            </a:xfrm>
+            <a:prstGeom prst="rect">
+              <a:avLst/>
+            </a:prstGeom>
+            <a:noFill/>
+          </p:spPr>
+          <p:txBody>
+            <a:bodyPr wrap="square" lIns="179285" tIns="143428" rIns="179285" bIns="143428" rtlCol="0">
+              <a:spAutoFit/>
+            </a:bodyPr>
+            <a:lstStyle/>
+            <a:p>
+              <a:pPr defTabSz="896386">
+                <a:lnSpc>
+                  <a:spcPct val="90000"/>
+                </a:lnSpc>
+                <a:spcAft>
+                  <a:spcPts val="588"/>
+                </a:spcAft>
+              </a:pPr>
+              <a:r>
+                <a:rPr lang="fr-FR" sz="1765" kern="0" dirty="0">
+                  <a:solidFill>
+                    <a:schemeClr val="bg1"/>
+                  </a:solidFill>
+                </a:rPr>
+                <a:t>Primitives • Collections • </a:t>
+              </a:r>
+              <a:r>
+                <a:rPr lang="fr-FR" sz="1765" kern="0" dirty="0" err="1">
+                  <a:solidFill>
+                    <a:schemeClr val="bg1"/>
+                  </a:solidFill>
+                </a:rPr>
+                <a:t>Reflection</a:t>
+              </a:r>
+              <a:r>
+                <a:rPr lang="fr-FR" sz="1765" kern="0" dirty="0">
+                  <a:solidFill>
+                    <a:schemeClr val="bg1"/>
+                  </a:solidFill>
+                </a:rPr>
+                <a:t> • </a:t>
+              </a:r>
+              <a:r>
+                <a:rPr lang="fr-FR" sz="1765" kern="0" dirty="0" err="1">
+                  <a:solidFill>
+                    <a:schemeClr val="bg1"/>
+                  </a:solidFill>
+                </a:rPr>
+                <a:t>Interop</a:t>
+              </a:r>
+              <a:r>
+                <a:rPr lang="fr-FR" sz="1765" kern="0" dirty="0">
+                  <a:solidFill>
+                    <a:schemeClr val="bg1"/>
+                  </a:solidFill>
+                </a:rPr>
+                <a:t> • </a:t>
+              </a:r>
+              <a:r>
+                <a:rPr lang="fr-FR" sz="1765" kern="0" dirty="0" err="1">
+                  <a:solidFill>
+                    <a:schemeClr val="bg1"/>
+                  </a:solidFill>
+                </a:rPr>
+                <a:t>Linq</a:t>
+              </a:r>
+              <a:endParaRPr lang="en-US" sz="1765" kern="0" dirty="0" err="1">
+                <a:solidFill>
+                  <a:schemeClr val="bg1"/>
+                </a:solidFill>
+              </a:endParaRPr>
+            </a:p>
+          </p:txBody>
+        </p:sp>
+        <p:sp>
+          <p:nvSpPr>
+            <p:cNvPr id="5" name="Rectangle 4"/>
+            <p:cNvSpPr/>
+            <p:nvPr/>
+          </p:nvSpPr>
+          <p:spPr>
+            <a:xfrm>
+              <a:off x="2560677" y="5676168"/>
+              <a:ext cx="777778" cy="341632"/>
+            </a:xfrm>
+            <a:prstGeom prst="rect">
+              <a:avLst/>
+            </a:prstGeom>
+          </p:spPr>
+          <p:txBody>
+            <a:bodyPr wrap="none">
+              <a:spAutoFit/>
+            </a:bodyPr>
+            <a:lstStyle/>
+            <a:p>
+              <a:pPr algn="ctr" defTabSz="914048">
+                <a:lnSpc>
+                  <a:spcPct val="90000"/>
+                </a:lnSpc>
+                <a:defRPr/>
+              </a:pPr>
+              <a:r>
+                <a:rPr lang="en-US" sz="1765" b="1" kern="0" dirty="0">
+                  <a:solidFill>
+                    <a:srgbClr val="FFFFFF"/>
+                  </a:solidFill>
+                  <a:cs typeface="Segoe UI Semibold" panose="020B0702040204020203" pitchFamily="34" charset="0"/>
+                </a:rPr>
+                <a:t>CORE</a:t>
+              </a:r>
+            </a:p>
+          </p:txBody>
+        </p:sp>
+      </p:grpSp>
+      <p:grpSp>
+        <p:nvGrpSpPr>
+          <p:cNvPr id="6" name="Group 5"/>
+          <p:cNvGrpSpPr/>
+          <p:nvPr/>
+        </p:nvGrpSpPr>
+        <p:grpSpPr>
+          <a:xfrm>
+            <a:off x="1986028" y="4952454"/>
+            <a:ext cx="8515943" cy="537849"/>
+            <a:chOff x="1646287" y="4881583"/>
+            <a:chExt cx="8686705" cy="548634"/>
+          </a:xfrm>
+        </p:grpSpPr>
+        <p:sp>
+          <p:nvSpPr>
+            <p:cNvPr id="7" name="Rectangle 6"/>
+            <p:cNvSpPr/>
+            <p:nvPr/>
+          </p:nvSpPr>
+          <p:spPr bwMode="auto">
+            <a:xfrm>
+              <a:off x="1646287" y="4881583"/>
+              <a:ext cx="8686705" cy="548634"/>
+            </a:xfrm>
+            <a:prstGeom prst="rect">
+              <a:avLst/>
+            </a:prstGeom>
+            <a:solidFill>
+              <a:srgbClr val="0078D7"/>
+            </a:solidFill>
+            <a:ln>
+              <a:noFill/>
+              <a:headEnd type="none" w="med" len="med"/>
+              <a:tailEnd type="none" w="med" len="med"/>
+            </a:ln>
+          </p:spPr>
+          <p:style>
+            <a:lnRef idx="2">
+              <a:schemeClr val="accent1">
+                <a:shade val="50000"/>
+              </a:schemeClr>
+            </a:lnRef>
+            <a:fillRef idx="1">
+              <a:schemeClr val="accent1"/>
+            </a:fillRef>
+            <a:effectRef idx="0">
+              <a:schemeClr val="accent1"/>
+            </a:effectRef>
+            <a:fontRef idx="minor">
+              <a:schemeClr val="lt1"/>
+            </a:fontRef>
+          </p:style>
+          <p:txBody>
+            <a:bodyPr rot="0" spcFirstLastPara="0" vertOverflow="overflow" horzOverflow="overflow" vert="horz" wrap="square" lIns="0" tIns="45720" rIns="0" bIns="45720" numCol="1" spcCol="0" rtlCol="0" fromWordArt="0" anchor="ctr" anchorCtr="0" forceAA="0" compatLnSpc="1">
+              <a:prstTxWarp prst="textNoShape">
+                <a:avLst/>
+              </a:prstTxWarp>
+              <a:noAutofit/>
+            </a:bodyPr>
+            <a:lstStyle/>
+            <a:p>
+              <a:pPr algn="ctr" defTabSz="914102" fontAlgn="base">
+                <a:spcBef>
+                  <a:spcPct val="0"/>
+                </a:spcBef>
+                <a:spcAft>
+                  <a:spcPct val="0"/>
+                </a:spcAft>
+              </a:pPr>
+              <a:endParaRPr lang="en-US" sz="1961" kern="0" dirty="0">
+                <a:gradFill>
+                  <a:gsLst>
+                    <a:gs pos="5439">
+                      <a:srgbClr val="F8F8F8"/>
+                    </a:gs>
+                    <a:gs pos="10000">
+                      <a:srgbClr val="F8F8F8"/>
+                    </a:gs>
+                  </a:gsLst>
+                  <a:lin ang="5400000" scaled="0"/>
+                </a:gradFill>
+              </a:endParaRPr>
+            </a:p>
+          </p:txBody>
+        </p:sp>
+        <p:sp>
+          <p:nvSpPr>
+            <p:cNvPr id="8" name="TextBox 7"/>
+            <p:cNvSpPr txBox="1"/>
+            <p:nvPr/>
+          </p:nvSpPr>
+          <p:spPr>
+            <a:xfrm>
+              <a:off x="4480896" y="4883518"/>
+              <a:ext cx="5577780" cy="544765"/>
+            </a:xfrm>
+            <a:prstGeom prst="rect">
+              <a:avLst/>
+            </a:prstGeom>
+            <a:noFill/>
+          </p:spPr>
+          <p:txBody>
+            <a:bodyPr wrap="square" lIns="179285" tIns="143428" rIns="179285" bIns="143428" rtlCol="0">
+              <a:spAutoFit/>
+            </a:bodyPr>
+            <a:lstStyle/>
+            <a:p>
+              <a:pPr defTabSz="896386">
+                <a:lnSpc>
+                  <a:spcPct val="90000"/>
+                </a:lnSpc>
+                <a:spcAft>
+                  <a:spcPts val="588"/>
+                </a:spcAft>
+              </a:pPr>
+              <a:r>
+                <a:rPr lang="fr-FR" sz="1765" kern="0" dirty="0">
+                  <a:solidFill>
+                    <a:schemeClr val="bg1"/>
+                  </a:solidFill>
+                </a:rPr>
+                <a:t>Threads • Thread Pool • </a:t>
+              </a:r>
+              <a:r>
+                <a:rPr lang="fr-FR" sz="1765" kern="0" dirty="0" err="1">
+                  <a:solidFill>
+                    <a:schemeClr val="bg1"/>
+                  </a:solidFill>
+                </a:rPr>
+                <a:t>Tasks</a:t>
+              </a:r>
+              <a:endParaRPr lang="en-US" sz="1765" kern="0" dirty="0" err="1">
+                <a:solidFill>
+                  <a:schemeClr val="bg1"/>
+                </a:solidFill>
+              </a:endParaRPr>
+            </a:p>
+          </p:txBody>
+        </p:sp>
+        <p:sp>
+          <p:nvSpPr>
+            <p:cNvPr id="9" name="Rectangle 8"/>
+            <p:cNvSpPr/>
+            <p:nvPr/>
+          </p:nvSpPr>
+          <p:spPr>
+            <a:xfrm>
+              <a:off x="2188782" y="4985084"/>
+              <a:ext cx="1521571" cy="341632"/>
+            </a:xfrm>
+            <a:prstGeom prst="rect">
+              <a:avLst/>
+            </a:prstGeom>
+          </p:spPr>
+          <p:txBody>
+            <a:bodyPr wrap="none">
+              <a:spAutoFit/>
+            </a:bodyPr>
+            <a:lstStyle/>
+            <a:p>
+              <a:pPr algn="ctr" defTabSz="914048">
+                <a:lnSpc>
+                  <a:spcPct val="90000"/>
+                </a:lnSpc>
+                <a:defRPr/>
+              </a:pPr>
+              <a:r>
+                <a:rPr lang="en-US" sz="1765" b="1" kern="0" dirty="0">
+                  <a:solidFill>
+                    <a:srgbClr val="FFFFFF"/>
+                  </a:solidFill>
+                  <a:cs typeface="Segoe UI Semibold" panose="020B0702040204020203" pitchFamily="34" charset="0"/>
+                </a:rPr>
+                <a:t>THREADING</a:t>
+              </a:r>
+            </a:p>
+          </p:txBody>
+        </p:sp>
+      </p:grpSp>
+      <p:grpSp>
+        <p:nvGrpSpPr>
+          <p:cNvPr id="10" name="Group 9"/>
+          <p:cNvGrpSpPr/>
+          <p:nvPr/>
+        </p:nvGrpSpPr>
+        <p:grpSpPr>
+          <a:xfrm>
+            <a:off x="1986028" y="4061468"/>
+            <a:ext cx="8515943" cy="537849"/>
+            <a:chOff x="1646287" y="4109887"/>
+            <a:chExt cx="8686705" cy="548634"/>
+          </a:xfrm>
+          <a:solidFill>
+            <a:srgbClr val="FF8C00"/>
+          </a:solidFill>
+        </p:grpSpPr>
+        <p:sp>
+          <p:nvSpPr>
+            <p:cNvPr id="11" name="Rectangle 10"/>
+            <p:cNvSpPr/>
+            <p:nvPr/>
+          </p:nvSpPr>
+          <p:spPr bwMode="auto">
+            <a:xfrm>
+              <a:off x="1646287" y="4109887"/>
+              <a:ext cx="8686705" cy="548634"/>
+            </a:xfrm>
+            <a:prstGeom prst="rect">
+              <a:avLst/>
+            </a:prstGeom>
+            <a:grpFill/>
+            <a:ln>
+              <a:noFill/>
+              <a:headEnd type="none" w="med" len="med"/>
+              <a:tailEnd type="none" w="med" len="med"/>
+            </a:ln>
+          </p:spPr>
+          <p:style>
+            <a:lnRef idx="2">
+              <a:schemeClr val="accent1">
+                <a:shade val="50000"/>
+              </a:schemeClr>
+            </a:lnRef>
+            <a:fillRef idx="1">
+              <a:schemeClr val="accent1"/>
+            </a:fillRef>
+            <a:effectRef idx="0">
+              <a:schemeClr val="accent1"/>
+            </a:effectRef>
+            <a:fontRef idx="minor">
+              <a:schemeClr val="lt1"/>
+            </a:fontRef>
+          </p:style>
+          <p:txBody>
+            <a:bodyPr rot="0" spcFirstLastPara="0" vertOverflow="overflow" horzOverflow="overflow" vert="horz" wrap="square" lIns="0" tIns="45720" rIns="0" bIns="45720" numCol="1" spcCol="0" rtlCol="0" fromWordArt="0" anchor="ctr" anchorCtr="0" forceAA="0" compatLnSpc="1">
+              <a:prstTxWarp prst="textNoShape">
+                <a:avLst/>
+              </a:prstTxWarp>
+              <a:noAutofit/>
+            </a:bodyPr>
+            <a:lstStyle/>
+            <a:p>
+              <a:pPr algn="ctr" defTabSz="914102" fontAlgn="base">
+                <a:spcBef>
+                  <a:spcPct val="0"/>
+                </a:spcBef>
+                <a:spcAft>
+                  <a:spcPct val="0"/>
+                </a:spcAft>
+              </a:pPr>
+              <a:endParaRPr lang="en-US" sz="1961" kern="0" dirty="0">
+                <a:gradFill>
+                  <a:gsLst>
+                    <a:gs pos="5439">
+                      <a:srgbClr val="F8F8F8"/>
+                    </a:gs>
+                    <a:gs pos="10000">
+                      <a:srgbClr val="F8F8F8"/>
+                    </a:gs>
+                  </a:gsLst>
+                  <a:lin ang="5400000" scaled="0"/>
+                </a:gradFill>
+              </a:endParaRPr>
+            </a:p>
+          </p:txBody>
+        </p:sp>
+        <p:sp>
+          <p:nvSpPr>
+            <p:cNvPr id="12" name="TextBox 11"/>
+            <p:cNvSpPr txBox="1"/>
+            <p:nvPr/>
+          </p:nvSpPr>
+          <p:spPr>
+            <a:xfrm>
+              <a:off x="4480896" y="4111822"/>
+              <a:ext cx="5577780" cy="544765"/>
+            </a:xfrm>
+            <a:prstGeom prst="rect">
+              <a:avLst/>
+            </a:prstGeom>
+            <a:grpFill/>
+          </p:spPr>
+          <p:txBody>
+            <a:bodyPr wrap="square" lIns="179285" tIns="143428" rIns="179285" bIns="143428" rtlCol="0">
+              <a:spAutoFit/>
+            </a:bodyPr>
+            <a:lstStyle/>
+            <a:p>
+              <a:pPr defTabSz="896386">
+                <a:lnSpc>
+                  <a:spcPct val="90000"/>
+                </a:lnSpc>
+                <a:spcAft>
+                  <a:spcPts val="588"/>
+                </a:spcAft>
+              </a:pPr>
+              <a:r>
+                <a:rPr lang="fr-FR" sz="1765" kern="0" dirty="0">
+                  <a:solidFill>
+                    <a:schemeClr val="bg1"/>
+                  </a:solidFill>
+                </a:rPr>
+                <a:t>Files • Compression • MMF</a:t>
+              </a:r>
+              <a:endParaRPr lang="en-US" sz="1765" kern="0" dirty="0" err="1">
+                <a:solidFill>
+                  <a:schemeClr val="bg1"/>
+                </a:solidFill>
+              </a:endParaRPr>
+            </a:p>
+          </p:txBody>
+        </p:sp>
+        <p:sp>
+          <p:nvSpPr>
+            <p:cNvPr id="13" name="Rectangle 12"/>
+            <p:cNvSpPr/>
+            <p:nvPr/>
+          </p:nvSpPr>
+          <p:spPr>
+            <a:xfrm>
+              <a:off x="2733000" y="4213388"/>
+              <a:ext cx="433132" cy="341632"/>
+            </a:xfrm>
+            <a:prstGeom prst="rect">
+              <a:avLst/>
+            </a:prstGeom>
+            <a:grpFill/>
+          </p:spPr>
+          <p:txBody>
+            <a:bodyPr wrap="none">
+              <a:spAutoFit/>
+            </a:bodyPr>
+            <a:lstStyle/>
+            <a:p>
+              <a:pPr algn="ctr" defTabSz="914048">
+                <a:lnSpc>
+                  <a:spcPct val="90000"/>
+                </a:lnSpc>
+                <a:defRPr/>
+              </a:pPr>
+              <a:r>
+                <a:rPr lang="en-US" sz="1765" b="1" kern="0" dirty="0">
+                  <a:solidFill>
+                    <a:srgbClr val="FFFFFF"/>
+                  </a:solidFill>
+                  <a:cs typeface="Segoe UI Semibold" panose="020B0702040204020203" pitchFamily="34" charset="0"/>
+                </a:rPr>
+                <a:t>IO</a:t>
+              </a:r>
+            </a:p>
+          </p:txBody>
+        </p:sp>
+      </p:grpSp>
+      <p:grpSp>
+        <p:nvGrpSpPr>
+          <p:cNvPr id="14" name="Group 13"/>
+          <p:cNvGrpSpPr/>
+          <p:nvPr/>
+        </p:nvGrpSpPr>
+        <p:grpSpPr>
+          <a:xfrm>
+            <a:off x="1986028" y="3170482"/>
+            <a:ext cx="8515943" cy="537849"/>
+            <a:chOff x="1646287" y="3278906"/>
+            <a:chExt cx="8686705" cy="548634"/>
+          </a:xfrm>
+          <a:solidFill>
+            <a:srgbClr val="00BCF2"/>
+          </a:solidFill>
+        </p:grpSpPr>
+        <p:sp>
+          <p:nvSpPr>
+            <p:cNvPr id="15" name="Rectangle 14"/>
+            <p:cNvSpPr/>
+            <p:nvPr/>
+          </p:nvSpPr>
+          <p:spPr bwMode="auto">
+            <a:xfrm>
+              <a:off x="1646287" y="3278906"/>
+              <a:ext cx="8686705" cy="548634"/>
+            </a:xfrm>
+            <a:prstGeom prst="rect">
+              <a:avLst/>
+            </a:prstGeom>
+            <a:grpFill/>
+            <a:ln>
+              <a:noFill/>
+              <a:headEnd type="none" w="med" len="med"/>
+              <a:tailEnd type="none" w="med" len="med"/>
+            </a:ln>
+          </p:spPr>
+          <p:style>
+            <a:lnRef idx="2">
+              <a:schemeClr val="accent1">
+                <a:shade val="50000"/>
+              </a:schemeClr>
+            </a:lnRef>
+            <a:fillRef idx="1">
+              <a:schemeClr val="accent1"/>
+            </a:fillRef>
+            <a:effectRef idx="0">
+              <a:schemeClr val="accent1"/>
+            </a:effectRef>
+            <a:fontRef idx="minor">
+              <a:schemeClr val="lt1"/>
+            </a:fontRef>
+          </p:style>
+          <p:txBody>
+            <a:bodyPr rot="0" spcFirstLastPara="0" vertOverflow="overflow" horzOverflow="overflow" vert="horz" wrap="square" lIns="0" tIns="45720" rIns="0" bIns="45720" numCol="1" spcCol="0" rtlCol="0" fromWordArt="0" anchor="ctr" anchorCtr="0" forceAA="0" compatLnSpc="1">
+              <a:prstTxWarp prst="textNoShape">
+                <a:avLst/>
+              </a:prstTxWarp>
+              <a:noAutofit/>
+            </a:bodyPr>
+            <a:lstStyle/>
+            <a:p>
+              <a:pPr algn="ctr" defTabSz="914102" fontAlgn="base">
+                <a:spcBef>
+                  <a:spcPct val="0"/>
+                </a:spcBef>
+                <a:spcAft>
+                  <a:spcPct val="0"/>
+                </a:spcAft>
+              </a:pPr>
+              <a:endParaRPr lang="en-US" sz="1961" kern="0" dirty="0">
+                <a:gradFill>
+                  <a:gsLst>
+                    <a:gs pos="5439">
+                      <a:srgbClr val="F8F8F8"/>
+                    </a:gs>
+                    <a:gs pos="10000">
+                      <a:srgbClr val="F8F8F8"/>
+                    </a:gs>
+                  </a:gsLst>
+                  <a:lin ang="5400000" scaled="0"/>
+                </a:gradFill>
+              </a:endParaRPr>
+            </a:p>
+          </p:txBody>
+        </p:sp>
+        <p:sp>
+          <p:nvSpPr>
+            <p:cNvPr id="16" name="TextBox 15"/>
+            <p:cNvSpPr txBox="1"/>
+            <p:nvPr/>
+          </p:nvSpPr>
+          <p:spPr>
+            <a:xfrm>
+              <a:off x="4480896" y="3280841"/>
+              <a:ext cx="5577780" cy="544765"/>
+            </a:xfrm>
+            <a:prstGeom prst="rect">
+              <a:avLst/>
+            </a:prstGeom>
+            <a:grpFill/>
+          </p:spPr>
+          <p:txBody>
+            <a:bodyPr wrap="square" lIns="179285" tIns="143428" rIns="179285" bIns="143428" rtlCol="0">
+              <a:spAutoFit/>
+            </a:bodyPr>
+            <a:lstStyle/>
+            <a:p>
+              <a:pPr defTabSz="896386">
+                <a:lnSpc>
+                  <a:spcPct val="90000"/>
+                </a:lnSpc>
+                <a:spcAft>
+                  <a:spcPts val="588"/>
+                </a:spcAft>
+              </a:pPr>
+              <a:r>
+                <a:rPr lang="fr-FR" sz="1765" kern="0" dirty="0">
+                  <a:solidFill>
+                    <a:schemeClr val="bg1"/>
+                  </a:solidFill>
+                </a:rPr>
+                <a:t>Sockets • Http • Mail • </a:t>
+              </a:r>
+              <a:r>
+                <a:rPr lang="fr-FR" sz="1765" kern="0" dirty="0" err="1">
+                  <a:solidFill>
+                    <a:schemeClr val="bg1"/>
+                  </a:solidFill>
+                </a:rPr>
+                <a:t>WebSockets</a:t>
+              </a:r>
+              <a:endParaRPr lang="en-US" sz="1765" kern="0" dirty="0" err="1">
+                <a:solidFill>
+                  <a:schemeClr val="bg1"/>
+                </a:solidFill>
+              </a:endParaRPr>
+            </a:p>
+          </p:txBody>
+        </p:sp>
+        <p:sp>
+          <p:nvSpPr>
+            <p:cNvPr id="17" name="Rectangle 16"/>
+            <p:cNvSpPr/>
+            <p:nvPr/>
+          </p:nvSpPr>
+          <p:spPr>
+            <a:xfrm>
+              <a:off x="2073366" y="3382407"/>
+              <a:ext cx="1752403" cy="341632"/>
+            </a:xfrm>
+            <a:prstGeom prst="rect">
+              <a:avLst/>
+            </a:prstGeom>
+            <a:grpFill/>
+          </p:spPr>
+          <p:txBody>
+            <a:bodyPr wrap="none">
+              <a:spAutoFit/>
+            </a:bodyPr>
+            <a:lstStyle/>
+            <a:p>
+              <a:pPr algn="ctr" defTabSz="914048">
+                <a:lnSpc>
+                  <a:spcPct val="90000"/>
+                </a:lnSpc>
+                <a:defRPr/>
+              </a:pPr>
+              <a:r>
+                <a:rPr lang="en-US" sz="1765" b="1" kern="0" dirty="0">
+                  <a:solidFill>
+                    <a:srgbClr val="FFFFFF"/>
+                  </a:solidFill>
+                  <a:cs typeface="Segoe UI Semibold" panose="020B0702040204020203" pitchFamily="34" charset="0"/>
+                </a:rPr>
+                <a:t>NETWORKING</a:t>
+              </a:r>
+            </a:p>
+          </p:txBody>
+        </p:sp>
+      </p:grpSp>
+      <p:grpSp>
+        <p:nvGrpSpPr>
+          <p:cNvPr id="18" name="Group 17"/>
+          <p:cNvGrpSpPr/>
+          <p:nvPr/>
+        </p:nvGrpSpPr>
+        <p:grpSpPr>
+          <a:xfrm>
+            <a:off x="1986028" y="2279496"/>
+            <a:ext cx="8515943" cy="537849"/>
+            <a:chOff x="1646287" y="2550596"/>
+            <a:chExt cx="8686705" cy="548634"/>
+          </a:xfrm>
+          <a:solidFill>
+            <a:srgbClr val="505050"/>
+          </a:solidFill>
+        </p:grpSpPr>
+        <p:sp>
+          <p:nvSpPr>
+            <p:cNvPr id="19" name="Rectangle 18"/>
+            <p:cNvSpPr/>
+            <p:nvPr/>
+          </p:nvSpPr>
+          <p:spPr bwMode="auto">
+            <a:xfrm>
+              <a:off x="1646287" y="2550596"/>
+              <a:ext cx="8686705" cy="548634"/>
+            </a:xfrm>
+            <a:prstGeom prst="rect">
+              <a:avLst/>
+            </a:prstGeom>
+            <a:grpFill/>
+            <a:ln>
+              <a:noFill/>
+              <a:headEnd type="none" w="med" len="med"/>
+              <a:tailEnd type="none" w="med" len="med"/>
+            </a:ln>
+          </p:spPr>
+          <p:style>
+            <a:lnRef idx="2">
+              <a:schemeClr val="accent1">
+                <a:shade val="50000"/>
+              </a:schemeClr>
+            </a:lnRef>
+            <a:fillRef idx="1">
+              <a:schemeClr val="accent1"/>
+            </a:fillRef>
+            <a:effectRef idx="0">
+              <a:schemeClr val="accent1"/>
+            </a:effectRef>
+            <a:fontRef idx="minor">
+              <a:schemeClr val="lt1"/>
+            </a:fontRef>
+          </p:style>
+          <p:txBody>
+            <a:bodyPr rot="0" spcFirstLastPara="0" vertOverflow="overflow" horzOverflow="overflow" vert="horz" wrap="square" lIns="0" tIns="45720" rIns="0" bIns="45720" numCol="1" spcCol="0" rtlCol="0" fromWordArt="0" anchor="ctr" anchorCtr="0" forceAA="0" compatLnSpc="1">
+              <a:prstTxWarp prst="textNoShape">
+                <a:avLst/>
+              </a:prstTxWarp>
+              <a:noAutofit/>
+            </a:bodyPr>
+            <a:lstStyle/>
+            <a:p>
+              <a:pPr algn="ctr" defTabSz="914102" fontAlgn="base">
+                <a:spcBef>
+                  <a:spcPct val="0"/>
+                </a:spcBef>
+                <a:spcAft>
+                  <a:spcPct val="0"/>
+                </a:spcAft>
+              </a:pPr>
+              <a:endParaRPr lang="en-US" sz="1961" kern="0" dirty="0">
+                <a:gradFill>
+                  <a:gsLst>
+                    <a:gs pos="5439">
+                      <a:srgbClr val="F8F8F8"/>
+                    </a:gs>
+                    <a:gs pos="10000">
+                      <a:srgbClr val="F8F8F8"/>
+                    </a:gs>
+                  </a:gsLst>
+                  <a:lin ang="5400000" scaled="0"/>
+                </a:gradFill>
+              </a:endParaRPr>
+            </a:p>
+          </p:txBody>
+        </p:sp>
+        <p:sp>
+          <p:nvSpPr>
+            <p:cNvPr id="20" name="TextBox 19"/>
+            <p:cNvSpPr txBox="1"/>
+            <p:nvPr/>
+          </p:nvSpPr>
+          <p:spPr>
+            <a:xfrm>
+              <a:off x="4480896" y="2552531"/>
+              <a:ext cx="5577780" cy="544765"/>
+            </a:xfrm>
+            <a:prstGeom prst="rect">
+              <a:avLst/>
+            </a:prstGeom>
+            <a:grpFill/>
+          </p:spPr>
+          <p:txBody>
+            <a:bodyPr wrap="square" lIns="179285" tIns="143428" rIns="179285" bIns="143428" rtlCol="0">
+              <a:spAutoFit/>
+            </a:bodyPr>
+            <a:lstStyle/>
+            <a:p>
+              <a:pPr defTabSz="896386">
+                <a:lnSpc>
+                  <a:spcPct val="90000"/>
+                </a:lnSpc>
+                <a:spcAft>
+                  <a:spcPts val="588"/>
+                </a:spcAft>
+              </a:pPr>
+              <a:r>
+                <a:rPr lang="fr-FR" sz="1765" kern="0" dirty="0" err="1">
+                  <a:solidFill>
+                    <a:schemeClr val="bg1"/>
+                  </a:solidFill>
+                </a:rPr>
+                <a:t>BinaryFormatter</a:t>
+              </a:r>
+              <a:r>
+                <a:rPr lang="fr-FR" sz="1765" kern="0" dirty="0">
+                  <a:solidFill>
+                    <a:schemeClr val="bg1"/>
+                  </a:solidFill>
+                </a:rPr>
+                <a:t> • Data </a:t>
+              </a:r>
+              <a:r>
+                <a:rPr lang="fr-FR" sz="1765" kern="0" dirty="0" err="1">
+                  <a:solidFill>
+                    <a:schemeClr val="bg1"/>
+                  </a:solidFill>
+                </a:rPr>
+                <a:t>Contract</a:t>
+              </a:r>
+              <a:r>
+                <a:rPr lang="fr-FR" sz="1765" kern="0" dirty="0">
+                  <a:solidFill>
+                    <a:schemeClr val="bg1"/>
+                  </a:solidFill>
+                </a:rPr>
+                <a:t> • XML</a:t>
+              </a:r>
+              <a:endParaRPr lang="en-US" sz="1765" kern="0" dirty="0" err="1">
+                <a:solidFill>
+                  <a:schemeClr val="bg1"/>
+                </a:solidFill>
+              </a:endParaRPr>
+            </a:p>
+          </p:txBody>
+        </p:sp>
+        <p:sp>
+          <p:nvSpPr>
+            <p:cNvPr id="21" name="Rectangle 20"/>
+            <p:cNvSpPr/>
+            <p:nvPr/>
+          </p:nvSpPr>
+          <p:spPr>
+            <a:xfrm>
+              <a:off x="2005923" y="2654097"/>
+              <a:ext cx="1887286" cy="343512"/>
+            </a:xfrm>
+            <a:prstGeom prst="rect">
+              <a:avLst/>
+            </a:prstGeom>
+            <a:grpFill/>
+          </p:spPr>
+          <p:txBody>
+            <a:bodyPr wrap="none">
+              <a:spAutoFit/>
+            </a:bodyPr>
+            <a:lstStyle/>
+            <a:p>
+              <a:pPr algn="ctr" defTabSz="914048">
+                <a:lnSpc>
+                  <a:spcPct val="90000"/>
+                </a:lnSpc>
+                <a:defRPr/>
+              </a:pPr>
+              <a:r>
+                <a:rPr lang="en-US" sz="1765" b="1" kern="0" dirty="0">
+                  <a:solidFill>
+                    <a:srgbClr val="FFFFFF"/>
+                  </a:solidFill>
+                  <a:cs typeface="Segoe UI Semibold" panose="020B0702040204020203" pitchFamily="34" charset="0"/>
+                </a:rPr>
+                <a:t>SERIALIZATION</a:t>
+              </a:r>
+            </a:p>
+          </p:txBody>
+        </p:sp>
+      </p:grpSp>
+      <p:grpSp>
+        <p:nvGrpSpPr>
+          <p:cNvPr id="22" name="Group 21"/>
+          <p:cNvGrpSpPr/>
+          <p:nvPr/>
+        </p:nvGrpSpPr>
+        <p:grpSpPr>
+          <a:xfrm>
+            <a:off x="1986028" y="1388510"/>
+            <a:ext cx="8515943" cy="537849"/>
+            <a:chOff x="1646287" y="1759921"/>
+            <a:chExt cx="8686705" cy="548634"/>
+          </a:xfrm>
+          <a:solidFill>
+            <a:srgbClr val="002050"/>
+          </a:solidFill>
+        </p:grpSpPr>
+        <p:sp>
+          <p:nvSpPr>
+            <p:cNvPr id="23" name="Rectangle 22"/>
+            <p:cNvSpPr/>
+            <p:nvPr/>
+          </p:nvSpPr>
+          <p:spPr bwMode="auto">
+            <a:xfrm>
+              <a:off x="1646287" y="1759921"/>
+              <a:ext cx="8686705" cy="548634"/>
+            </a:xfrm>
+            <a:prstGeom prst="rect">
+              <a:avLst/>
+            </a:prstGeom>
+            <a:grpFill/>
+            <a:ln>
+              <a:noFill/>
+              <a:headEnd type="none" w="med" len="med"/>
+              <a:tailEnd type="none" w="med" len="med"/>
+            </a:ln>
+          </p:spPr>
+          <p:style>
+            <a:lnRef idx="2">
+              <a:schemeClr val="accent1">
+                <a:shade val="50000"/>
+              </a:schemeClr>
+            </a:lnRef>
+            <a:fillRef idx="1">
+              <a:schemeClr val="accent1"/>
+            </a:fillRef>
+            <a:effectRef idx="0">
+              <a:schemeClr val="accent1"/>
+            </a:effectRef>
+            <a:fontRef idx="minor">
+              <a:schemeClr val="lt1"/>
+            </a:fontRef>
+          </p:style>
+          <p:txBody>
+            <a:bodyPr rot="0" spcFirstLastPara="0" vertOverflow="overflow" horzOverflow="overflow" vert="horz" wrap="square" lIns="0" tIns="45720" rIns="0" bIns="45720" numCol="1" spcCol="0" rtlCol="0" fromWordArt="0" anchor="ctr" anchorCtr="0" forceAA="0" compatLnSpc="1">
+              <a:prstTxWarp prst="textNoShape">
+                <a:avLst/>
+              </a:prstTxWarp>
+              <a:noAutofit/>
+            </a:bodyPr>
+            <a:lstStyle/>
+            <a:p>
+              <a:pPr algn="ctr" defTabSz="914102" fontAlgn="base">
+                <a:spcBef>
+                  <a:spcPct val="0"/>
+                </a:spcBef>
+                <a:spcAft>
+                  <a:spcPct val="0"/>
+                </a:spcAft>
+              </a:pPr>
+              <a:endParaRPr lang="en-US" sz="1961" kern="0" dirty="0">
+                <a:gradFill>
+                  <a:gsLst>
+                    <a:gs pos="5439">
+                      <a:srgbClr val="F8F8F8"/>
+                    </a:gs>
+                    <a:gs pos="10000">
+                      <a:srgbClr val="F8F8F8"/>
+                    </a:gs>
+                  </a:gsLst>
+                  <a:lin ang="5400000" scaled="0"/>
+                </a:gradFill>
+              </a:endParaRPr>
+            </a:p>
+          </p:txBody>
+        </p:sp>
+        <p:sp>
+          <p:nvSpPr>
+            <p:cNvPr id="24" name="TextBox 23"/>
+            <p:cNvSpPr txBox="1"/>
+            <p:nvPr/>
+          </p:nvSpPr>
+          <p:spPr>
+            <a:xfrm>
+              <a:off x="4480896" y="1761856"/>
+              <a:ext cx="5577780" cy="544793"/>
+            </a:xfrm>
+            <a:prstGeom prst="rect">
+              <a:avLst/>
+            </a:prstGeom>
+            <a:grpFill/>
+          </p:spPr>
+          <p:txBody>
+            <a:bodyPr wrap="square" lIns="179285" tIns="143428" rIns="179285" bIns="143428" rtlCol="0">
+              <a:spAutoFit/>
+            </a:bodyPr>
+            <a:lstStyle/>
+            <a:p>
+              <a:pPr defTabSz="896386">
+                <a:lnSpc>
+                  <a:spcPct val="90000"/>
+                </a:lnSpc>
+                <a:spcAft>
+                  <a:spcPts val="588"/>
+                </a:spcAft>
+              </a:pPr>
+              <a:r>
+                <a:rPr lang="fr-FR" sz="1765" kern="0" dirty="0" err="1">
+                  <a:solidFill>
+                    <a:schemeClr val="bg1"/>
+                  </a:solidFill>
+                </a:rPr>
+                <a:t>XLinq</a:t>
+              </a:r>
+              <a:r>
+                <a:rPr lang="fr-FR" sz="1765" kern="0" dirty="0">
+                  <a:solidFill>
+                    <a:schemeClr val="bg1"/>
+                  </a:solidFill>
+                </a:rPr>
+                <a:t> • XML Document  • </a:t>
+              </a:r>
+              <a:r>
+                <a:rPr lang="fr-FR" sz="1765" kern="0" dirty="0" err="1">
+                  <a:solidFill>
+                    <a:schemeClr val="bg1"/>
+                  </a:solidFill>
+                </a:rPr>
+                <a:t>XPath</a:t>
+              </a:r>
+              <a:r>
+                <a:rPr lang="fr-FR" sz="1765" kern="0" dirty="0">
+                  <a:solidFill>
+                    <a:schemeClr val="bg1"/>
+                  </a:solidFill>
+                </a:rPr>
+                <a:t> • XSD • XSL</a:t>
+              </a:r>
+              <a:endParaRPr lang="en-US" sz="1765" kern="0" dirty="0" err="1">
+                <a:solidFill>
+                  <a:schemeClr val="bg1"/>
+                </a:solidFill>
+              </a:endParaRPr>
+            </a:p>
+          </p:txBody>
+        </p:sp>
+        <p:sp>
+          <p:nvSpPr>
+            <p:cNvPr id="25" name="Rectangle 24"/>
+            <p:cNvSpPr/>
+            <p:nvPr/>
+          </p:nvSpPr>
+          <p:spPr>
+            <a:xfrm>
+              <a:off x="2611973" y="1863422"/>
+              <a:ext cx="675185" cy="341632"/>
+            </a:xfrm>
+            <a:prstGeom prst="rect">
+              <a:avLst/>
+            </a:prstGeom>
+            <a:grpFill/>
+          </p:spPr>
+          <p:txBody>
+            <a:bodyPr wrap="none">
+              <a:spAutoFit/>
+            </a:bodyPr>
+            <a:lstStyle/>
+            <a:p>
+              <a:pPr algn="ctr" defTabSz="914048">
+                <a:lnSpc>
+                  <a:spcPct val="90000"/>
+                </a:lnSpc>
+                <a:defRPr/>
+              </a:pPr>
+              <a:r>
+                <a:rPr lang="en-US" sz="1765" b="1" kern="0" dirty="0">
+                  <a:solidFill>
+                    <a:srgbClr val="FFFFFF"/>
+                  </a:solidFill>
+                  <a:cs typeface="Segoe UI Semibold" panose="020B0702040204020203" pitchFamily="34" charset="0"/>
+                </a:rPr>
+                <a:t>XML</a:t>
+              </a:r>
+            </a:p>
+          </p:txBody>
+        </p:sp>
+      </p:grpSp>
+      <p:sp>
+        <p:nvSpPr>
+          <p:cNvPr id="27" name="Rectangle 26"/>
+          <p:cNvSpPr/>
+          <p:nvPr/>
+        </p:nvSpPr>
+        <p:spPr>
+          <a:xfrm>
+            <a:off x="4892787" y="778341"/>
+            <a:ext cx="2406428" cy="341632"/>
+          </a:xfrm>
+          <a:prstGeom prst="rect">
+            <a:avLst/>
+          </a:prstGeom>
+        </p:spPr>
+        <p:txBody>
+          <a:bodyPr wrap="none">
+            <a:spAutoFit/>
+          </a:bodyPr>
+          <a:lstStyle/>
+          <a:p>
+            <a:pPr lvl="0" algn="ctr" defTabSz="914224">
+              <a:lnSpc>
+                <a:spcPct val="90000"/>
+              </a:lnSpc>
+              <a:defRPr/>
+            </a:pPr>
+            <a:r>
+              <a:rPr lang="en-US" b="1" kern="0" dirty="0">
+                <a:solidFill>
+                  <a:sysClr val="windowText" lastClr="000000"/>
+                </a:solidFill>
+                <a:latin typeface="Segoe UI"/>
+                <a:cs typeface="Segoe UI Semibold" panose="020B0702040204020203" pitchFamily="34" charset="0"/>
+              </a:rPr>
+              <a:t>.NET STANDARD 2.0</a:t>
+            </a:r>
+          </a:p>
+        </p:txBody>
+      </p:sp>
+    </p:spTree>
+    <p:extLst>
+      <p:ext uri="{BB962C8B-B14F-4D97-AF65-F5344CB8AC3E}">
+        <p14:creationId xmlns:p14="http://schemas.microsoft.com/office/powerpoint/2010/main" val="3455506390"/>
+      </p:ext>
+    </p:extLst>
+  </p:cSld>
+  <p:clrMapOvr>
+    <a:masterClrMapping/>
+  </p:clrMapOvr>
+  <p:timing>
+    <p:tnLst>
+      <p:par>
+        <p:cTn id="1" dur="indefinite" restart="never" nodeType="tmRoot">
+          <p:childTnLst>
+            <p:seq concurrent="1" nextAc="seek">
+              <p:cTn id="2" dur="indefinite" nodeType="mainSeq">
+                <p:childTnLst>
+                  <p:par>
+                    <p:cTn id="3" fill="hold">
+                      <p:stCondLst>
+                        <p:cond delay="indefinite"/>
+                        <p:cond evt="onBegin" delay="0">
+                          <p:tn val="2"/>
+                        </p:cond>
+                      </p:stCondLst>
+                      <p:childTnLst>
+                        <p:par>
+                          <p:cTn id="4" fill="hold">
+                            <p:stCondLst>
+                              <p:cond delay="0"/>
+                            </p:stCondLst>
+                            <p:childTnLst>
+                              <p:par>
+                                <p:cTn id="5" presetID="2" presetClass="entr" presetSubtype="2" fill="hold" nodeType="withEffect">
+                                  <p:stCondLst>
+                                    <p:cond delay="0"/>
+                                  </p:stCondLst>
+                                  <p:childTnLst>
+                                    <p:set>
+                                      <p:cBhvr>
+                                        <p:cTn id="6" dur="1" fill="hold">
+                                          <p:stCondLst>
+                                            <p:cond delay="0"/>
+                                          </p:stCondLst>
+                                        </p:cTn>
+                                        <p:tgtEl>
+                                          <p:spTgt spid="2"/>
+                                        </p:tgtEl>
+                                        <p:attrNameLst>
+                                          <p:attrName>style.visibility</p:attrName>
+                                        </p:attrNameLst>
+                                      </p:cBhvr>
+                                      <p:to>
+                                        <p:strVal val="visible"/>
+                                      </p:to>
+                                    </p:set>
+                                    <p:anim calcmode="lin" valueType="num">
+                                      <p:cBhvr additive="base">
+                                        <p:cTn id="7" dur="500" fill="hold"/>
+                                        <p:tgtEl>
+                                          <p:spTgt spid="2"/>
+                                        </p:tgtEl>
+                                        <p:attrNameLst>
+                                          <p:attrName>ppt_x</p:attrName>
+                                        </p:attrNameLst>
+                                      </p:cBhvr>
+                                      <p:tavLst>
+                                        <p:tav tm="0">
+                                          <p:val>
+                                            <p:strVal val="1+#ppt_w/2"/>
+                                          </p:val>
+                                        </p:tav>
+                                        <p:tav tm="100000">
+                                          <p:val>
+                                            <p:strVal val="#ppt_x"/>
+                                          </p:val>
+                                        </p:tav>
+                                      </p:tavLst>
+                                    </p:anim>
+                                    <p:anim calcmode="lin" valueType="num">
+                                      <p:cBhvr additive="base">
+                                        <p:cTn id="8" dur="500" fill="hold"/>
+                                        <p:tgtEl>
+                                          <p:spTgt spid="2"/>
+                                        </p:tgtEl>
+                                        <p:attrNameLst>
+                                          <p:attrName>ppt_y</p:attrName>
+                                        </p:attrNameLst>
+                                      </p:cBhvr>
+                                      <p:tavLst>
+                                        <p:tav tm="0">
+                                          <p:val>
+                                            <p:strVal val="#ppt_y"/>
+                                          </p:val>
+                                        </p:tav>
+                                        <p:tav tm="100000">
+                                          <p:val>
+                                            <p:strVal val="#ppt_y"/>
+                                          </p:val>
+                                        </p:tav>
+                                      </p:tavLst>
+                                    </p:anim>
+                                  </p:childTnLst>
+                                </p:cTn>
+                              </p:par>
+                            </p:childTnLst>
+                          </p:cTn>
+                        </p:par>
+                        <p:par>
+                          <p:cTn id="9" fill="hold">
+                            <p:stCondLst>
+                              <p:cond delay="500"/>
+                            </p:stCondLst>
+                            <p:childTnLst>
+                              <p:par>
+                                <p:cTn id="10" presetID="2" presetClass="entr" presetSubtype="2" fill="hold" nodeType="afterEffect">
+                                  <p:stCondLst>
+                                    <p:cond delay="0"/>
+                                  </p:stCondLst>
+                                  <p:childTnLst>
+                                    <p:set>
+                                      <p:cBhvr>
+                                        <p:cTn id="11" dur="1" fill="hold">
+                                          <p:stCondLst>
+                                            <p:cond delay="0"/>
+                                          </p:stCondLst>
+                                        </p:cTn>
+                                        <p:tgtEl>
+                                          <p:spTgt spid="6"/>
+                                        </p:tgtEl>
+                                        <p:attrNameLst>
+                                          <p:attrName>style.visibility</p:attrName>
+                                        </p:attrNameLst>
+                                      </p:cBhvr>
+                                      <p:to>
+                                        <p:strVal val="visible"/>
+                                      </p:to>
+                                    </p:set>
+                                    <p:anim calcmode="lin" valueType="num">
+                                      <p:cBhvr additive="base">
+                                        <p:cTn id="12" dur="750" fill="hold"/>
+                                        <p:tgtEl>
+                                          <p:spTgt spid="6"/>
+                                        </p:tgtEl>
+                                        <p:attrNameLst>
+                                          <p:attrName>ppt_x</p:attrName>
+                                        </p:attrNameLst>
+                                      </p:cBhvr>
+                                      <p:tavLst>
+                                        <p:tav tm="0">
+                                          <p:val>
+                                            <p:strVal val="1+#ppt_w/2"/>
+                                          </p:val>
+                                        </p:tav>
+                                        <p:tav tm="100000">
+                                          <p:val>
+                                            <p:strVal val="#ppt_x"/>
+                                          </p:val>
+                                        </p:tav>
+                                      </p:tavLst>
+                                    </p:anim>
+                                    <p:anim calcmode="lin" valueType="num">
+                                      <p:cBhvr additive="base">
+                                        <p:cTn id="13" dur="750" fill="hold"/>
+                                        <p:tgtEl>
+                                          <p:spTgt spid="6"/>
+                                        </p:tgtEl>
+                                        <p:attrNameLst>
+                                          <p:attrName>ppt_y</p:attrName>
+                                        </p:attrNameLst>
+                                      </p:cBhvr>
+                                      <p:tavLst>
+                                        <p:tav tm="0">
+                                          <p:val>
+                                            <p:strVal val="#ppt_y"/>
+                                          </p:val>
+                                        </p:tav>
+                                        <p:tav tm="100000">
+                                          <p:val>
+                                            <p:strVal val="#ppt_y"/>
+                                          </p:val>
+                                        </p:tav>
+                                      </p:tavLst>
+                                    </p:anim>
+                                  </p:childTnLst>
+                                </p:cTn>
+                              </p:par>
+                            </p:childTnLst>
+                          </p:cTn>
+                        </p:par>
+                        <p:par>
+                          <p:cTn id="14" fill="hold">
+                            <p:stCondLst>
+                              <p:cond delay="1250"/>
+                            </p:stCondLst>
+                            <p:childTnLst>
+                              <p:par>
+                                <p:cTn id="15" presetID="2" presetClass="entr" presetSubtype="2" fill="hold" nodeType="afterEffect">
+                                  <p:stCondLst>
+                                    <p:cond delay="0"/>
+                                  </p:stCondLst>
+                                  <p:childTnLst>
+                                    <p:set>
+                                      <p:cBhvr>
+                                        <p:cTn id="16" dur="1" fill="hold">
+                                          <p:stCondLst>
+                                            <p:cond delay="0"/>
+                                          </p:stCondLst>
+                                        </p:cTn>
+                                        <p:tgtEl>
+                                          <p:spTgt spid="10"/>
+                                        </p:tgtEl>
+                                        <p:attrNameLst>
+                                          <p:attrName>style.visibility</p:attrName>
+                                        </p:attrNameLst>
+                                      </p:cBhvr>
+                                      <p:to>
+                                        <p:strVal val="visible"/>
+                                      </p:to>
+                                    </p:set>
+                                    <p:anim calcmode="lin" valueType="num">
+                                      <p:cBhvr additive="base">
+                                        <p:cTn id="17" dur="750" fill="hold"/>
+                                        <p:tgtEl>
+                                          <p:spTgt spid="10"/>
+                                        </p:tgtEl>
+                                        <p:attrNameLst>
+                                          <p:attrName>ppt_x</p:attrName>
+                                        </p:attrNameLst>
+                                      </p:cBhvr>
+                                      <p:tavLst>
+                                        <p:tav tm="0">
+                                          <p:val>
+                                            <p:strVal val="1+#ppt_w/2"/>
+                                          </p:val>
+                                        </p:tav>
+                                        <p:tav tm="100000">
+                                          <p:val>
+                                            <p:strVal val="#ppt_x"/>
+                                          </p:val>
+                                        </p:tav>
+                                      </p:tavLst>
+                                    </p:anim>
+                                    <p:anim calcmode="lin" valueType="num">
+                                      <p:cBhvr additive="base">
+                                        <p:cTn id="18" dur="750" fill="hold"/>
+                                        <p:tgtEl>
+                                          <p:spTgt spid="10"/>
+                                        </p:tgtEl>
+                                        <p:attrNameLst>
+                                          <p:attrName>ppt_y</p:attrName>
+                                        </p:attrNameLst>
+                                      </p:cBhvr>
+                                      <p:tavLst>
+                                        <p:tav tm="0">
+                                          <p:val>
+                                            <p:strVal val="#ppt_y"/>
+                                          </p:val>
+                                        </p:tav>
+                                        <p:tav tm="100000">
+                                          <p:val>
+                                            <p:strVal val="#ppt_y"/>
+                                          </p:val>
+                                        </p:tav>
+                                      </p:tavLst>
+                                    </p:anim>
+                                  </p:childTnLst>
+                                </p:cTn>
+                              </p:par>
+                            </p:childTnLst>
+                          </p:cTn>
+                        </p:par>
+                        <p:par>
+                          <p:cTn id="19" fill="hold">
+                            <p:stCondLst>
+                              <p:cond delay="2000"/>
+                            </p:stCondLst>
+                            <p:childTnLst>
+                              <p:par>
+                                <p:cTn id="20" presetID="2" presetClass="entr" presetSubtype="2" fill="hold" nodeType="afterEffect">
+                                  <p:stCondLst>
+                                    <p:cond delay="0"/>
+                                  </p:stCondLst>
+                                  <p:childTnLst>
+                                    <p:set>
+                                      <p:cBhvr>
+                                        <p:cTn id="21" dur="1" fill="hold">
+                                          <p:stCondLst>
+                                            <p:cond delay="0"/>
+                                          </p:stCondLst>
+                                        </p:cTn>
+                                        <p:tgtEl>
+                                          <p:spTgt spid="14"/>
+                                        </p:tgtEl>
+                                        <p:attrNameLst>
+                                          <p:attrName>style.visibility</p:attrName>
+                                        </p:attrNameLst>
+                                      </p:cBhvr>
+                                      <p:to>
+                                        <p:strVal val="visible"/>
+                                      </p:to>
+                                    </p:set>
+                                    <p:anim calcmode="lin" valueType="num">
+                                      <p:cBhvr additive="base">
+                                        <p:cTn id="22" dur="750" fill="hold"/>
+                                        <p:tgtEl>
+                                          <p:spTgt spid="14"/>
+                                        </p:tgtEl>
+                                        <p:attrNameLst>
+                                          <p:attrName>ppt_x</p:attrName>
+                                        </p:attrNameLst>
+                                      </p:cBhvr>
+                                      <p:tavLst>
+                                        <p:tav tm="0">
+                                          <p:val>
+                                            <p:strVal val="1+#ppt_w/2"/>
+                                          </p:val>
+                                        </p:tav>
+                                        <p:tav tm="100000">
+                                          <p:val>
+                                            <p:strVal val="#ppt_x"/>
+                                          </p:val>
+                                        </p:tav>
+                                      </p:tavLst>
+                                    </p:anim>
+                                    <p:anim calcmode="lin" valueType="num">
+                                      <p:cBhvr additive="base">
+                                        <p:cTn id="23" dur="750" fill="hold"/>
+                                        <p:tgtEl>
+                                          <p:spTgt spid="14"/>
+                                        </p:tgtEl>
+                                        <p:attrNameLst>
+                                          <p:attrName>ppt_y</p:attrName>
+                                        </p:attrNameLst>
+                                      </p:cBhvr>
+                                      <p:tavLst>
+                                        <p:tav tm="0">
+                                          <p:val>
+                                            <p:strVal val="#ppt_y"/>
+                                          </p:val>
+                                        </p:tav>
+                                        <p:tav tm="100000">
+                                          <p:val>
+                                            <p:strVal val="#ppt_y"/>
+                                          </p:val>
+                                        </p:tav>
+                                      </p:tavLst>
+                                    </p:anim>
+                                  </p:childTnLst>
+                                </p:cTn>
+                              </p:par>
+                            </p:childTnLst>
+                          </p:cTn>
+                        </p:par>
+                        <p:par>
+                          <p:cTn id="24" fill="hold">
+                            <p:stCondLst>
+                              <p:cond delay="2750"/>
+                            </p:stCondLst>
+                            <p:childTnLst>
+                              <p:par>
+                                <p:cTn id="25" presetID="2" presetClass="entr" presetSubtype="2" fill="hold" nodeType="afterEffect">
+                                  <p:stCondLst>
+                                    <p:cond delay="0"/>
+                                  </p:stCondLst>
+                                  <p:childTnLst>
+                                    <p:set>
+                                      <p:cBhvr>
+                                        <p:cTn id="26" dur="1" fill="hold">
+                                          <p:stCondLst>
+                                            <p:cond delay="0"/>
+                                          </p:stCondLst>
+                                        </p:cTn>
+                                        <p:tgtEl>
+                                          <p:spTgt spid="18"/>
+                                        </p:tgtEl>
+                                        <p:attrNameLst>
+                                          <p:attrName>style.visibility</p:attrName>
+                                        </p:attrNameLst>
+                                      </p:cBhvr>
+                                      <p:to>
+                                        <p:strVal val="visible"/>
+                                      </p:to>
+                                    </p:set>
+                                    <p:anim calcmode="lin" valueType="num">
+                                      <p:cBhvr additive="base">
+                                        <p:cTn id="27" dur="750" fill="hold"/>
+                                        <p:tgtEl>
+                                          <p:spTgt spid="18"/>
+                                        </p:tgtEl>
+                                        <p:attrNameLst>
+                                          <p:attrName>ppt_x</p:attrName>
+                                        </p:attrNameLst>
+                                      </p:cBhvr>
+                                      <p:tavLst>
+                                        <p:tav tm="0">
+                                          <p:val>
+                                            <p:strVal val="1+#ppt_w/2"/>
+                                          </p:val>
+                                        </p:tav>
+                                        <p:tav tm="100000">
+                                          <p:val>
+                                            <p:strVal val="#ppt_x"/>
+                                          </p:val>
+                                        </p:tav>
+                                      </p:tavLst>
+                                    </p:anim>
+                                    <p:anim calcmode="lin" valueType="num">
+                                      <p:cBhvr additive="base">
+                                        <p:cTn id="28" dur="750" fill="hold"/>
+                                        <p:tgtEl>
+                                          <p:spTgt spid="18"/>
+                                        </p:tgtEl>
+                                        <p:attrNameLst>
+                                          <p:attrName>ppt_y</p:attrName>
+                                        </p:attrNameLst>
+                                      </p:cBhvr>
+                                      <p:tavLst>
+                                        <p:tav tm="0">
+                                          <p:val>
+                                            <p:strVal val="#ppt_y"/>
+                                          </p:val>
+                                        </p:tav>
+                                        <p:tav tm="100000">
+                                          <p:val>
+                                            <p:strVal val="#ppt_y"/>
+                                          </p:val>
+                                        </p:tav>
+                                      </p:tavLst>
+                                    </p:anim>
+                                  </p:childTnLst>
+                                </p:cTn>
+                              </p:par>
+                            </p:childTnLst>
+                          </p:cTn>
+                        </p:par>
+                        <p:par>
+                          <p:cTn id="29" fill="hold">
+                            <p:stCondLst>
+                              <p:cond delay="3500"/>
+                            </p:stCondLst>
+                            <p:childTnLst>
+                              <p:par>
+                                <p:cTn id="30" presetID="2" presetClass="entr" presetSubtype="2" fill="hold" nodeType="afterEffect">
+                                  <p:stCondLst>
+                                    <p:cond delay="0"/>
+                                  </p:stCondLst>
+                                  <p:childTnLst>
+                                    <p:set>
+                                      <p:cBhvr>
+                                        <p:cTn id="31" dur="1" fill="hold">
+                                          <p:stCondLst>
+                                            <p:cond delay="0"/>
+                                          </p:stCondLst>
+                                        </p:cTn>
+                                        <p:tgtEl>
+                                          <p:spTgt spid="22"/>
+                                        </p:tgtEl>
+                                        <p:attrNameLst>
+                                          <p:attrName>style.visibility</p:attrName>
+                                        </p:attrNameLst>
+                                      </p:cBhvr>
+                                      <p:to>
+                                        <p:strVal val="visible"/>
+                                      </p:to>
+                                    </p:set>
+                                    <p:anim calcmode="lin" valueType="num">
+                                      <p:cBhvr additive="base">
+                                        <p:cTn id="32" dur="750" fill="hold"/>
+                                        <p:tgtEl>
+                                          <p:spTgt spid="22"/>
+                                        </p:tgtEl>
+                                        <p:attrNameLst>
+                                          <p:attrName>ppt_x</p:attrName>
+                                        </p:attrNameLst>
+                                      </p:cBhvr>
+                                      <p:tavLst>
+                                        <p:tav tm="0">
+                                          <p:val>
+                                            <p:strVal val="1+#ppt_w/2"/>
+                                          </p:val>
+                                        </p:tav>
+                                        <p:tav tm="100000">
+                                          <p:val>
+                                            <p:strVal val="#ppt_x"/>
+                                          </p:val>
+                                        </p:tav>
+                                      </p:tavLst>
+                                    </p:anim>
+                                    <p:anim calcmode="lin" valueType="num">
+                                      <p:cBhvr additive="base">
+                                        <p:cTn id="33" dur="750" fill="hold"/>
+                                        <p:tgtEl>
+                                          <p:spTgt spid="22"/>
+                                        </p:tgtEl>
+                                        <p:attrNameLst>
+                                          <p:attrName>ppt_y</p:attrName>
+                                        </p:attrNameLst>
+                                      </p:cBhvr>
+                                      <p:tavLst>
+                                        <p:tav tm="0">
+                                          <p:val>
+                                            <p:strVal val="#ppt_y"/>
+                                          </p:val>
+                                        </p:tav>
+                                        <p:tav tm="100000">
+                                          <p:val>
+                                            <p:strVal val="#ppt_y"/>
+                                          </p:val>
+                                        </p:tav>
+                                      </p:tavLst>
+                                    </p:anim>
+                                  </p:childTnLst>
+                                </p:cTn>
+                              </p:par>
+                            </p:childTnLst>
+                          </p:cTn>
+                        </p:par>
+                      </p:childTnLst>
+                    </p:cTn>
+                  </p:par>
+                </p:childTnLst>
+              </p:cTn>
+              <p:prevCondLst>
+                <p:cond evt="onPrev" delay="0">
+                  <p:tgtEl>
+                    <p:sldTgt/>
+                  </p:tgtEl>
+                </p:cond>
+              </p:prevCondLst>
+              <p:nextCondLst>
+                <p:cond evt="onNext" delay="0">
+                  <p:tgtEl>
+                    <p:sldTgt/>
+                  </p:tgtEl>
+                </p:cond>
+              </p:nextCondLst>
+            </p:seq>
+          </p:childTnLst>
+        </p:cTn>
+      </p:par>
+    </p:tnLst>
+  </p:timing>
+</p:sld>
+</file>
+
+<file path=ppt/slides/slide4.xml><?xml version="1.0" encoding="utf-8"?>
+<p:sld xmlns:a="http://schemas.openxmlformats.org/drawingml/2006/main" xmlns:r="http://schemas.openxmlformats.org/officeDocument/2006/relationships" xmlns:p="http://schemas.openxmlformats.org/presentationml/2006/main">
+  <p:cSld>
+    <p:spTree>
+      <p:nvGrpSpPr>
+        <p:cNvPr id="1" name=""/>
+        <p:cNvGrpSpPr/>
+        <p:nvPr/>
+      </p:nvGrpSpPr>
+      <p:grpSpPr>
+        <a:xfrm>
+          <a:off x="0" y="0"/>
+          <a:ext cx="0" cy="0"/>
+          <a:chOff x="0" y="0"/>
+          <a:chExt cx="0" cy="0"/>
+        </a:xfrm>
+      </p:grpSpPr>
+      <p:sp>
+        <p:nvSpPr>
           <p:cNvPr id="4" name="Rectangle 3"/>
           <p:cNvSpPr/>
           <p:nvPr/>
@@ -7704,7 +9544,7 @@
 </p:sld>
 </file>
 
-<file path=ppt/slides/slide4.xml><?xml version="1.0" encoding="utf-8"?>
+<file path=ppt/slides/slide5.xml><?xml version="1.0" encoding="utf-8"?>
 <p:sld xmlns:a="http://schemas.openxmlformats.org/drawingml/2006/main" xmlns:r="http://schemas.openxmlformats.org/officeDocument/2006/relationships" xmlns:p="http://schemas.openxmlformats.org/presentationml/2006/main">
   <p:cSld>
     <p:spTree>

</xml_diff>